<commit_message>
build(pptx,dashboard): DE 스타 플레이어 핵심 콜아웃 + 블루·그린 절제 (v2.32.1)
- 3장 모두에 "DE를 스타 플레이어로 — 고객사와 기술 생태계 공동 구축" 콜아웃,
  '모난 놈이 정 맞는' 문화 → 호명 문화 전환 부제 (wiki §4.6 근거)
- 컬러 절제: 뉴트럴 그레이 기본, 강조색은 To-Be·SCA·DE 콜아웃·핵심 숫자에만
- 다운로드 pptx 3종 재생성·미러, DT_DOWNLOADS 설명 갱신, v2.32.1 (패치)

Co-Authored-By: Claude Fable 5 <noreply@anthropic.com>
Claude-Session: https://claude.ai/code/session_01P75FajBNDiW5p24ay2HU9V
</commit_message>
<xml_diff>
--- a/dashboard/public/downloads/dev-transformation-summary-high.pptx
+++ b/dashboard/public/downloads/dev-transformation-summary-high.pptx
@@ -924,7 +924,7 @@
             </a:avLst>
           </a:prstGeom>
           <a:solidFill>
-            <a:srgbClr val="EAF3FA"/>
+            <a:srgbClr val="EFF3F5"/>
           </a:solidFill>
           <a:ln/>
         </p:spPr>
@@ -938,7 +938,7 @@
             <a:r>
               <a:rPr lang="en-US" sz="1400" b="1" dirty="0">
                 <a:solidFill>
-                  <a:srgbClr val="0E6BA8"/>
+                  <a:srgbClr val="5A7184"/>
                 </a:solidFill>
                 <a:latin typeface="Malgun Gothic" pitchFamily="34" charset="0"/>
                 <a:ea typeface="Malgun Gothic" pitchFamily="34" charset="-122"/>
@@ -1098,7 +1098,7 @@
             </a:avLst>
           </a:prstGeom>
           <a:solidFill>
-            <a:srgbClr val="EAF3FA"/>
+            <a:srgbClr val="F5F7F8"/>
           </a:solidFill>
           <a:ln/>
         </p:spPr>
@@ -1118,7 +1118,7 @@
             <a:avLst/>
           </a:prstGeom>
           <a:solidFill>
-            <a:srgbClr val="0E6BA8"/>
+            <a:srgbClr val="17313B"/>
           </a:solidFill>
           <a:ln/>
         </p:spPr>
@@ -1171,7 +1171,7 @@
             <a:r>
               <a:rPr lang="en-US" sz="2100" b="1" dirty="0">
                 <a:solidFill>
-                  <a:srgbClr val="0E6BA8"/>
+                  <a:srgbClr val="17313B"/>
                 </a:solidFill>
                 <a:latin typeface="Malgun Gothic" pitchFamily="34" charset="0"/>
                 <a:ea typeface="Malgun Gothic" pitchFamily="34" charset="-122"/>
@@ -1200,7 +1200,7 @@
             </a:avLst>
           </a:prstGeom>
           <a:solidFill>
-            <a:srgbClr val="E6F4F4"/>
+            <a:srgbClr val="F5F7F8"/>
           </a:solidFill>
           <a:ln/>
         </p:spPr>
@@ -1220,7 +1220,7 @@
             <a:avLst/>
           </a:prstGeom>
           <a:solidFill>
-            <a:srgbClr val="028090"/>
+            <a:srgbClr val="17313B"/>
           </a:solidFill>
           <a:ln/>
         </p:spPr>
@@ -1273,7 +1273,7 @@
             <a:r>
               <a:rPr lang="en-US" sz="2100" b="1" dirty="0">
                 <a:solidFill>
-                  <a:srgbClr val="028090"/>
+                  <a:srgbClr val="17313B"/>
                 </a:solidFill>
                 <a:latin typeface="Malgun Gothic" pitchFamily="34" charset="0"/>
                 <a:ea typeface="Malgun Gothic" pitchFamily="34" charset="-122"/>
@@ -1302,7 +1302,7 @@
             </a:avLst>
           </a:prstGeom>
           <a:solidFill>
-            <a:srgbClr val="E8F6F0"/>
+            <a:srgbClr val="F5F7F8"/>
           </a:solidFill>
           <a:ln/>
         </p:spPr>
@@ -1322,7 +1322,7 @@
             <a:avLst/>
           </a:prstGeom>
           <a:solidFill>
-            <a:srgbClr val="02A878"/>
+            <a:srgbClr val="17313B"/>
           </a:solidFill>
           <a:ln/>
         </p:spPr>
@@ -1375,7 +1375,7 @@
             <a:r>
               <a:rPr lang="en-US" sz="2100" b="1" dirty="0">
                 <a:solidFill>
-                  <a:srgbClr val="02A878"/>
+                  <a:srgbClr val="17313B"/>
                 </a:solidFill>
                 <a:latin typeface="Malgun Gothic" pitchFamily="34" charset="0"/>
                 <a:ea typeface="Malgun Gothic" pitchFamily="34" charset="-122"/>
@@ -1404,7 +1404,7 @@
           <a:noFill/>
           <a:ln w="19050">
             <a:solidFill>
-              <a:srgbClr val="0E6BA8"/>
+              <a:srgbClr val="C4CFD6"/>
             </a:solidFill>
             <a:prstDash val="solid"/>
           </a:ln>
@@ -1425,7 +1425,7 @@
             <a:avLst/>
           </a:prstGeom>
           <a:solidFill>
-            <a:srgbClr val="0E6BA8"/>
+            <a:srgbClr val="17313B"/>
           </a:solidFill>
           <a:ln/>
         </p:spPr>
@@ -1457,7 +1457,7 @@
             <a:r>
               <a:rPr lang="en-US" sz="1400" b="1" dirty="0">
                 <a:solidFill>
-                  <a:srgbClr val="0E6BA8"/>
+                  <a:srgbClr val="17313B"/>
                 </a:solidFill>
                 <a:latin typeface="Malgun Gothic" pitchFamily="34" charset="0"/>
                 <a:ea typeface="Malgun Gothic" pitchFamily="34" charset="-122"/>
@@ -1546,7 +1546,7 @@
             <a:avLst/>
           </a:prstGeom>
           <a:solidFill>
-            <a:srgbClr val="0E6BA8"/>
+            <a:srgbClr val="17313B"/>
           </a:solidFill>
           <a:ln/>
         </p:spPr>
@@ -1578,7 +1578,7 @@
             <a:r>
               <a:rPr lang="en-US" sz="1400" b="1" dirty="0">
                 <a:solidFill>
-                  <a:srgbClr val="0E6BA8"/>
+                  <a:srgbClr val="17313B"/>
                 </a:solidFill>
                 <a:latin typeface="Malgun Gothic" pitchFamily="34" charset="0"/>
                 <a:ea typeface="Malgun Gothic" pitchFamily="34" charset="-122"/>
@@ -1667,7 +1667,7 @@
             <a:avLst/>
           </a:prstGeom>
           <a:solidFill>
-            <a:srgbClr val="0E6BA8"/>
+            <a:srgbClr val="17313B"/>
           </a:solidFill>
           <a:ln/>
         </p:spPr>
@@ -1699,7 +1699,7 @@
             <a:r>
               <a:rPr lang="en-US" sz="1400" b="1" dirty="0">
                 <a:solidFill>
-                  <a:srgbClr val="0E6BA8"/>
+                  <a:srgbClr val="17313B"/>
                 </a:solidFill>
                 <a:latin typeface="Malgun Gothic" pitchFamily="34" charset="0"/>
                 <a:ea typeface="Malgun Gothic" pitchFamily="34" charset="-122"/>
@@ -1794,7 +1794,7 @@
           </a:solidFill>
           <a:ln w="12700">
             <a:solidFill>
-              <a:srgbClr val="0E6BA8"/>
+              <a:srgbClr val="DCE4E9"/>
             </a:solidFill>
             <a:prstDash val="solid"/>
           </a:ln>
@@ -1985,7 +1985,7 @@
           </a:solidFill>
           <a:ln w="12700">
             <a:solidFill>
-              <a:srgbClr val="D9E6EC"/>
+              <a:srgbClr val="DCE4E9"/>
             </a:solidFill>
           </a:ln>
         </p:spPr>
@@ -2118,7 +2118,7 @@
           </a:solidFill>
           <a:ln w="12700">
             <a:solidFill>
-              <a:srgbClr val="D9E6EC"/>
+              <a:srgbClr val="DCE4E9"/>
             </a:solidFill>
           </a:ln>
         </p:spPr>
@@ -2251,7 +2251,7 @@
           </a:solidFill>
           <a:ln w="12700">
             <a:solidFill>
-              <a:srgbClr val="D9E6EC"/>
+              <a:srgbClr val="DCE4E9"/>
             </a:solidFill>
           </a:ln>
         </p:spPr>
@@ -2384,7 +2384,7 @@
           </a:solidFill>
           <a:ln w="12700">
             <a:solidFill>
-              <a:srgbClr val="D9E6EC"/>
+              <a:srgbClr val="DCE4E9"/>
             </a:solidFill>
           </a:ln>
         </p:spPr>
@@ -2517,7 +2517,7 @@
           </a:solidFill>
           <a:ln w="12700">
             <a:solidFill>
-              <a:srgbClr val="028090"/>
+              <a:srgbClr val="DCE4E9"/>
             </a:solidFill>
             <a:prstDash val="solid"/>
           </a:ln>
@@ -2594,14 +2594,14 @@
         </p:nvSpPr>
         <p:spPr>
           <a:xfrm>
-            <a:off x="8842248" y="1956816"/>
-            <a:ext cx="475488" cy="475488"/>
+            <a:off x="8897112" y="1847088"/>
+            <a:ext cx="402336" cy="402336"/>
           </a:xfrm>
           <a:prstGeom prst="ellipse">
             <a:avLst/>
           </a:prstGeom>
           <a:solidFill>
-            <a:srgbClr val="0E6BA8"/>
+            <a:srgbClr val="5A7184"/>
           </a:solidFill>
           <a:ln/>
         </p:spPr>
@@ -2622,8 +2622,8 @@
         </p:blipFill>
         <p:spPr>
           <a:xfrm>
-            <a:off x="8956365" y="2070933"/>
-            <a:ext cx="247254" cy="247254"/>
+            <a:off x="8993673" y="1943649"/>
+            <a:ext cx="209215" cy="209215"/>
           </a:xfrm>
           <a:prstGeom prst="rect">
             <a:avLst/>
@@ -2638,8 +2638,8 @@
         </p:nvSpPr>
         <p:spPr>
           <a:xfrm>
-            <a:off x="8330184" y="2468880"/>
-            <a:ext cx="1499616" cy="292608"/>
+            <a:off x="8330184" y="2267712"/>
+            <a:ext cx="1536192" cy="274320"/>
           </a:xfrm>
           <a:prstGeom prst="rect">
             <a:avLst/>
@@ -2655,7 +2655,7 @@
               <a:buNone/>
             </a:pPr>
             <a:r>
-              <a:rPr lang="en-US" sz="1600" b="1" dirty="0">
+              <a:rPr lang="en-US" sz="1500" b="1" dirty="0">
                 <a:solidFill>
                   <a:srgbClr val="17313B"/>
                 </a:solidFill>
@@ -2665,7 +2665,7 @@
               </a:rPr>
               <a:t>기술</a:t>
             </a:r>
-            <a:endParaRPr lang="en-US" sz="1600" dirty="0"/>
+            <a:endParaRPr lang="en-US" sz="1500" dirty="0"/>
           </a:p>
         </p:txBody>
       </p:sp>
@@ -2677,8 +2677,8 @@
         </p:nvSpPr>
         <p:spPr>
           <a:xfrm>
-            <a:off x="8275320" y="2761488"/>
-            <a:ext cx="1609344" cy="237744"/>
+            <a:off x="8275320" y="2542032"/>
+            <a:ext cx="1645920" cy="219456"/>
           </a:xfrm>
           <a:prstGeom prst="rect">
             <a:avLst/>
@@ -2694,7 +2694,7 @@
               <a:buNone/>
             </a:pPr>
             <a:r>
-              <a:rPr lang="en-US" sz="1100" dirty="0">
+              <a:rPr lang="en-US" sz="1050" dirty="0">
                 <a:solidFill>
                   <a:srgbClr val="5A7184"/>
                 </a:solidFill>
@@ -2704,7 +2704,7 @@
               </a:rPr>
               <a:t>워크로드 랩·모델</a:t>
             </a:r>
-            <a:endParaRPr lang="en-US" sz="1100" dirty="0"/>
+            <a:endParaRPr lang="en-US" sz="1050" dirty="0"/>
           </a:p>
         </p:txBody>
       </p:sp>
@@ -2716,14 +2716,14 @@
         </p:nvSpPr>
         <p:spPr>
           <a:xfrm>
-            <a:off x="10506456" y="1956816"/>
-            <a:ext cx="475488" cy="475488"/>
+            <a:off x="10561320" y="1847088"/>
+            <a:ext cx="402336" cy="402336"/>
           </a:xfrm>
           <a:prstGeom prst="ellipse">
             <a:avLst/>
           </a:prstGeom>
           <a:solidFill>
-            <a:srgbClr val="028090"/>
+            <a:srgbClr val="5A7184"/>
           </a:solidFill>
           <a:ln/>
         </p:spPr>
@@ -2744,8 +2744,8 @@
         </p:blipFill>
         <p:spPr>
           <a:xfrm>
-            <a:off x="10620573" y="2070933"/>
-            <a:ext cx="247254" cy="247254"/>
+            <a:off x="10657881" y="1943649"/>
+            <a:ext cx="209215" cy="209215"/>
           </a:xfrm>
           <a:prstGeom prst="rect">
             <a:avLst/>
@@ -2760,8 +2760,8 @@
         </p:nvSpPr>
         <p:spPr>
           <a:xfrm>
-            <a:off x="9994392" y="2468880"/>
-            <a:ext cx="1499616" cy="292608"/>
+            <a:off x="9994392" y="2267712"/>
+            <a:ext cx="1536192" cy="274320"/>
           </a:xfrm>
           <a:prstGeom prst="rect">
             <a:avLst/>
@@ -2777,7 +2777,7 @@
               <a:buNone/>
             </a:pPr>
             <a:r>
-              <a:rPr lang="en-US" sz="1600" b="1" dirty="0">
+              <a:rPr lang="en-US" sz="1500" b="1" dirty="0">
                 <a:solidFill>
                   <a:srgbClr val="17313B"/>
                 </a:solidFill>
@@ -2787,7 +2787,7 @@
               </a:rPr>
               <a:t>문화</a:t>
             </a:r>
-            <a:endParaRPr lang="en-US" sz="1600" dirty="0"/>
+            <a:endParaRPr lang="en-US" sz="1500" dirty="0"/>
           </a:p>
         </p:txBody>
       </p:sp>
@@ -2799,8 +2799,8 @@
         </p:nvSpPr>
         <p:spPr>
           <a:xfrm>
-            <a:off x="9939528" y="2761488"/>
-            <a:ext cx="1609344" cy="237744"/>
+            <a:off x="9939528" y="2542032"/>
+            <a:ext cx="1645920" cy="219456"/>
           </a:xfrm>
           <a:prstGeom prst="rect">
             <a:avLst/>
@@ -2816,7 +2816,7 @@
               <a:buNone/>
             </a:pPr>
             <a:r>
-              <a:rPr lang="en-US" sz="1100" dirty="0">
+              <a:rPr lang="en-US" sz="1050" dirty="0">
                 <a:solidFill>
                   <a:srgbClr val="5A7184"/>
                 </a:solidFill>
@@ -2824,9 +2824,9 @@
                 <a:ea typeface="Malgun Gothic" pitchFamily="34" charset="-122"/>
                 <a:cs typeface="Malgun Gothic" pitchFamily="34" charset="-120"/>
               </a:rPr>
-              <a:t>가설 제안·호명</a:t>
-            </a:r>
-            <a:endParaRPr lang="en-US" sz="1100" dirty="0"/>
+              <a:t>모난 놈 → 호명</a:t>
+            </a:r>
+            <a:endParaRPr lang="en-US" sz="1050" dirty="0"/>
           </a:p>
         </p:txBody>
       </p:sp>
@@ -2838,14 +2838,14 @@
         </p:nvSpPr>
         <p:spPr>
           <a:xfrm>
-            <a:off x="8842248" y="3200400"/>
-            <a:ext cx="475488" cy="475488"/>
+            <a:off x="8897112" y="2907792"/>
+            <a:ext cx="402336" cy="402336"/>
           </a:xfrm>
           <a:prstGeom prst="ellipse">
             <a:avLst/>
           </a:prstGeom>
           <a:solidFill>
-            <a:srgbClr val="02A878"/>
+            <a:srgbClr val="5A7184"/>
           </a:solidFill>
           <a:ln/>
         </p:spPr>
@@ -2866,8 +2866,8 @@
         </p:blipFill>
         <p:spPr>
           <a:xfrm>
-            <a:off x="8956365" y="3314517"/>
-            <a:ext cx="247254" cy="247254"/>
+            <a:off x="8993673" y="3004353"/>
+            <a:ext cx="209215" cy="209215"/>
           </a:xfrm>
           <a:prstGeom prst="rect">
             <a:avLst/>
@@ -2882,8 +2882,8 @@
         </p:nvSpPr>
         <p:spPr>
           <a:xfrm>
-            <a:off x="8330184" y="3712464"/>
-            <a:ext cx="1499616" cy="292608"/>
+            <a:off x="8330184" y="3328416"/>
+            <a:ext cx="1536192" cy="274320"/>
           </a:xfrm>
           <a:prstGeom prst="rect">
             <a:avLst/>
@@ -2899,7 +2899,7 @@
               <a:buNone/>
             </a:pPr>
             <a:r>
-              <a:rPr lang="en-US" sz="1600" b="1" dirty="0">
+              <a:rPr lang="en-US" sz="1500" b="1" dirty="0">
                 <a:solidFill>
                   <a:srgbClr val="17313B"/>
                 </a:solidFill>
@@ -2909,7 +2909,7 @@
               </a:rPr>
               <a:t>조직</a:t>
             </a:r>
-            <a:endParaRPr lang="en-US" sz="1600" dirty="0"/>
+            <a:endParaRPr lang="en-US" sz="1500" dirty="0"/>
           </a:p>
         </p:txBody>
       </p:sp>
@@ -2921,8 +2921,8 @@
         </p:nvSpPr>
         <p:spPr>
           <a:xfrm>
-            <a:off x="8275320" y="4005072"/>
-            <a:ext cx="1609344" cy="237744"/>
+            <a:off x="8275320" y="3602736"/>
+            <a:ext cx="1645920" cy="219456"/>
           </a:xfrm>
           <a:prstGeom prst="rect">
             <a:avLst/>
@@ -2938,7 +2938,7 @@
               <a:buNone/>
             </a:pPr>
             <a:r>
-              <a:rPr lang="en-US" sz="1100" dirty="0">
+              <a:rPr lang="en-US" sz="1050" dirty="0">
                 <a:solidFill>
                   <a:srgbClr val="5A7184"/>
                 </a:solidFill>
@@ -2946,9 +2946,9 @@
                 <a:ea typeface="Malgun Gothic" pitchFamily="34" charset="-122"/>
                 <a:cs typeface="Malgun Gothic" pitchFamily="34" charset="-120"/>
               </a:rPr>
-              <a:t>Pod·DE 트랙</a:t>
-            </a:r>
-            <a:endParaRPr lang="en-US" sz="1100" dirty="0"/>
+              <a:t>DE 스타·Pod 상주</a:t>
+            </a:r>
+            <a:endParaRPr lang="en-US" sz="1050" dirty="0"/>
           </a:p>
         </p:txBody>
       </p:sp>
@@ -2960,14 +2960,14 @@
         </p:nvSpPr>
         <p:spPr>
           <a:xfrm>
-            <a:off x="10506456" y="3200400"/>
-            <a:ext cx="475488" cy="475488"/>
+            <a:off x="10561320" y="2907792"/>
+            <a:ext cx="402336" cy="402336"/>
           </a:xfrm>
           <a:prstGeom prst="ellipse">
             <a:avLst/>
           </a:prstGeom>
           <a:solidFill>
-            <a:srgbClr val="4C7C94"/>
+            <a:srgbClr val="5A7184"/>
           </a:solidFill>
           <a:ln/>
         </p:spPr>
@@ -2988,8 +2988,8 @@
         </p:blipFill>
         <p:spPr>
           <a:xfrm>
-            <a:off x="10620573" y="3314517"/>
-            <a:ext cx="247254" cy="247254"/>
+            <a:off x="10657881" y="3004353"/>
+            <a:ext cx="209215" cy="209215"/>
           </a:xfrm>
           <a:prstGeom prst="rect">
             <a:avLst/>
@@ -3004,8 +3004,8 @@
         </p:nvSpPr>
         <p:spPr>
           <a:xfrm>
-            <a:off x="9994392" y="3712464"/>
-            <a:ext cx="1499616" cy="292608"/>
+            <a:off x="9994392" y="3328416"/>
+            <a:ext cx="1536192" cy="274320"/>
           </a:xfrm>
           <a:prstGeom prst="rect">
             <a:avLst/>
@@ -3021,7 +3021,7 @@
               <a:buNone/>
             </a:pPr>
             <a:r>
-              <a:rPr lang="en-US" sz="1600" b="1" dirty="0">
+              <a:rPr lang="en-US" sz="1500" b="1" dirty="0">
                 <a:solidFill>
                   <a:srgbClr val="17313B"/>
                 </a:solidFill>
@@ -3031,7 +3031,7 @@
               </a:rPr>
               <a:t>방식</a:t>
             </a:r>
-            <a:endParaRPr lang="en-US" sz="1600" dirty="0"/>
+            <a:endParaRPr lang="en-US" sz="1500" dirty="0"/>
           </a:p>
         </p:txBody>
       </p:sp>
@@ -3043,8 +3043,8 @@
         </p:nvSpPr>
         <p:spPr>
           <a:xfrm>
-            <a:off x="9939528" y="4005072"/>
-            <a:ext cx="1609344" cy="237744"/>
+            <a:off x="9939528" y="3602736"/>
+            <a:ext cx="1645920" cy="219456"/>
           </a:xfrm>
           <a:prstGeom prst="rect">
             <a:avLst/>
@@ -3060,7 +3060,7 @@
               <a:buNone/>
             </a:pPr>
             <a:r>
-              <a:rPr lang="en-US" sz="1100" dirty="0">
+              <a:rPr lang="en-US" sz="1050" dirty="0">
                 <a:solidFill>
                   <a:srgbClr val="5A7184"/>
                 </a:solidFill>
@@ -3070,7 +3070,7 @@
               </a:rPr>
               <a:t>교차 리뷰·PoA</a:t>
             </a:r>
-            <a:endParaRPr lang="en-US" sz="1100" dirty="0"/>
+            <a:endParaRPr lang="en-US" sz="1050" dirty="0"/>
           </a:p>
         </p:txBody>
       </p:sp>
@@ -3082,7 +3082,7 @@
         </p:nvSpPr>
         <p:spPr>
           <a:xfrm>
-            <a:off x="8695944" y="4828032"/>
+            <a:off x="8695944" y="4206240"/>
             <a:ext cx="2468880" cy="0"/>
           </a:xfrm>
           <a:prstGeom prst="line">
@@ -3090,6 +3090,279 @@
           </a:prstGeom>
           <a:noFill/>
           <a:ln w="19050">
+            <a:solidFill>
+              <a:srgbClr val="C4CFD6"/>
+            </a:solidFill>
+            <a:prstDash val="solid"/>
+          </a:ln>
+        </p:spPr>
+      </p:sp>
+      <p:sp>
+        <p:nvSpPr>
+          <p:cNvPr id="63" name="Shape 55"/>
+          <p:cNvSpPr/>
+          <p:nvPr/>
+        </p:nvSpPr>
+        <p:spPr>
+          <a:xfrm>
+            <a:off x="8631936" y="4142232"/>
+            <a:ext cx="128016" cy="128016"/>
+          </a:xfrm>
+          <a:prstGeom prst="ellipse">
+            <a:avLst/>
+          </a:prstGeom>
+          <a:solidFill>
+            <a:srgbClr val="17313B"/>
+          </a:solidFill>
+          <a:ln/>
+        </p:spPr>
+      </p:sp>
+      <p:sp>
+        <p:nvSpPr>
+          <p:cNvPr id="64" name="Text 56"/>
+          <p:cNvSpPr/>
+          <p:nvPr/>
+        </p:nvSpPr>
+        <p:spPr>
+          <a:xfrm>
+            <a:off x="8147304" y="4334256"/>
+            <a:ext cx="1097280" cy="457200"/>
+          </a:xfrm>
+          <a:prstGeom prst="rect">
+            <a:avLst/>
+          </a:prstGeom>
+          <a:noFill/>
+          <a:ln/>
+        </p:spPr>
+        <p:txBody>
+          <a:bodyPr wrap="square" lIns="0" tIns="0" rIns="0" bIns="0" rtlCol="0" anchor="ctr"/>
+          <a:lstStyle/>
+          <a:p>
+            <a:pPr algn="ctr" indent="0" marL="0">
+              <a:lnSpc>
+                <a:spcPct val="100000"/>
+              </a:lnSpc>
+              <a:buNone/>
+            </a:pPr>
+            <a:r>
+              <a:rPr lang="en-US" sz="1150" b="1" dirty="0">
+                <a:solidFill>
+                  <a:srgbClr val="17313B"/>
+                </a:solidFill>
+                <a:latin typeface="Malgun Gothic" pitchFamily="34" charset="0"/>
+                <a:ea typeface="Malgun Gothic" pitchFamily="34" charset="-122"/>
+                <a:cs typeface="Malgun Gothic" pitchFamily="34" charset="-120"/>
+              </a:rPr>
+              <a:t>90일</a:t>
+            </a:r>
+            <a:endParaRPr lang="en-US" sz="1150" dirty="0"/>
+          </a:p>
+          <a:p>
+            <a:pPr algn="ctr" indent="0" marL="0">
+              <a:lnSpc>
+                <a:spcPct val="100000"/>
+              </a:lnSpc>
+              <a:buNone/>
+            </a:pPr>
+            <a:r>
+              <a:rPr lang="en-US" sz="1150" b="1" dirty="0">
+                <a:solidFill>
+                  <a:srgbClr val="17313B"/>
+                </a:solidFill>
+                <a:latin typeface="Malgun Gothic" pitchFamily="34" charset="0"/>
+                <a:ea typeface="Malgun Gothic" pitchFamily="34" charset="-122"/>
+                <a:cs typeface="Malgun Gothic" pitchFamily="34" charset="-120"/>
+              </a:rPr>
+              <a:t>증명</a:t>
+            </a:r>
+            <a:endParaRPr lang="en-US" sz="1150" dirty="0"/>
+          </a:p>
+        </p:txBody>
+      </p:sp>
+      <p:sp>
+        <p:nvSpPr>
+          <p:cNvPr id="65" name="Shape 57"/>
+          <p:cNvSpPr/>
+          <p:nvPr/>
+        </p:nvSpPr>
+        <p:spPr>
+          <a:xfrm>
+            <a:off x="9866376" y="4142232"/>
+            <a:ext cx="128016" cy="128016"/>
+          </a:xfrm>
+          <a:prstGeom prst="ellipse">
+            <a:avLst/>
+          </a:prstGeom>
+          <a:solidFill>
+            <a:srgbClr val="17313B"/>
+          </a:solidFill>
+          <a:ln/>
+        </p:spPr>
+      </p:sp>
+      <p:sp>
+        <p:nvSpPr>
+          <p:cNvPr id="66" name="Text 58"/>
+          <p:cNvSpPr/>
+          <p:nvPr/>
+        </p:nvSpPr>
+        <p:spPr>
+          <a:xfrm>
+            <a:off x="9381744" y="4334256"/>
+            <a:ext cx="1097280" cy="457200"/>
+          </a:xfrm>
+          <a:prstGeom prst="rect">
+            <a:avLst/>
+          </a:prstGeom>
+          <a:noFill/>
+          <a:ln/>
+        </p:spPr>
+        <p:txBody>
+          <a:bodyPr wrap="square" lIns="0" tIns="0" rIns="0" bIns="0" rtlCol="0" anchor="ctr"/>
+          <a:lstStyle/>
+          <a:p>
+            <a:pPr algn="ctr" indent="0" marL="0">
+              <a:lnSpc>
+                <a:spcPct val="100000"/>
+              </a:lnSpc>
+              <a:buNone/>
+            </a:pPr>
+            <a:r>
+              <a:rPr lang="en-US" sz="1150" b="1" dirty="0">
+                <a:solidFill>
+                  <a:srgbClr val="17313B"/>
+                </a:solidFill>
+                <a:latin typeface="Malgun Gothic" pitchFamily="34" charset="0"/>
+                <a:ea typeface="Malgun Gothic" pitchFamily="34" charset="-122"/>
+                <a:cs typeface="Malgun Gothic" pitchFamily="34" charset="-120"/>
+              </a:rPr>
+              <a:t>1년</a:t>
+            </a:r>
+            <a:endParaRPr lang="en-US" sz="1150" dirty="0"/>
+          </a:p>
+          <a:p>
+            <a:pPr algn="ctr" indent="0" marL="0">
+              <a:lnSpc>
+                <a:spcPct val="100000"/>
+              </a:lnSpc>
+              <a:buNone/>
+            </a:pPr>
+            <a:r>
+              <a:rPr lang="en-US" sz="1150" b="1" dirty="0">
+                <a:solidFill>
+                  <a:srgbClr val="17313B"/>
+                </a:solidFill>
+                <a:latin typeface="Malgun Gothic" pitchFamily="34" charset="0"/>
+                <a:ea typeface="Malgun Gothic" pitchFamily="34" charset="-122"/>
+                <a:cs typeface="Malgun Gothic" pitchFamily="34" charset="-120"/>
+              </a:rPr>
+              <a:t>제도화</a:t>
+            </a:r>
+            <a:endParaRPr lang="en-US" sz="1150" dirty="0"/>
+          </a:p>
+        </p:txBody>
+      </p:sp>
+      <p:sp>
+        <p:nvSpPr>
+          <p:cNvPr id="67" name="Shape 59"/>
+          <p:cNvSpPr/>
+          <p:nvPr/>
+        </p:nvSpPr>
+        <p:spPr>
+          <a:xfrm>
+            <a:off x="11100816" y="4142232"/>
+            <a:ext cx="128016" cy="128016"/>
+          </a:xfrm>
+          <a:prstGeom prst="ellipse">
+            <a:avLst/>
+          </a:prstGeom>
+          <a:solidFill>
+            <a:srgbClr val="17313B"/>
+          </a:solidFill>
+          <a:ln/>
+        </p:spPr>
+      </p:sp>
+      <p:sp>
+        <p:nvSpPr>
+          <p:cNvPr id="68" name="Text 60"/>
+          <p:cNvSpPr/>
+          <p:nvPr/>
+        </p:nvSpPr>
+        <p:spPr>
+          <a:xfrm>
+            <a:off x="10616184" y="4334256"/>
+            <a:ext cx="1097280" cy="457200"/>
+          </a:xfrm>
+          <a:prstGeom prst="rect">
+            <a:avLst/>
+          </a:prstGeom>
+          <a:noFill/>
+          <a:ln/>
+        </p:spPr>
+        <p:txBody>
+          <a:bodyPr wrap="square" lIns="0" tIns="0" rIns="0" bIns="0" rtlCol="0" anchor="ctr"/>
+          <a:lstStyle/>
+          <a:p>
+            <a:pPr algn="ctr" indent="0" marL="0">
+              <a:lnSpc>
+                <a:spcPct val="100000"/>
+              </a:lnSpc>
+              <a:buNone/>
+            </a:pPr>
+            <a:r>
+              <a:rPr lang="en-US" sz="1150" b="1" dirty="0">
+                <a:solidFill>
+                  <a:srgbClr val="17313B"/>
+                </a:solidFill>
+                <a:latin typeface="Malgun Gothic" pitchFamily="34" charset="0"/>
+                <a:ea typeface="Malgun Gothic" pitchFamily="34" charset="-122"/>
+                <a:cs typeface="Malgun Gothic" pitchFamily="34" charset="-120"/>
+              </a:rPr>
+              <a:t>3년</a:t>
+            </a:r>
+            <a:endParaRPr lang="en-US" sz="1150" dirty="0"/>
+          </a:p>
+          <a:p>
+            <a:pPr algn="ctr" indent="0" marL="0">
+              <a:lnSpc>
+                <a:spcPct val="100000"/>
+              </a:lnSpc>
+              <a:buNone/>
+            </a:pPr>
+            <a:r>
+              <a:rPr lang="en-US" sz="1150" b="1" dirty="0">
+                <a:solidFill>
+                  <a:srgbClr val="17313B"/>
+                </a:solidFill>
+                <a:latin typeface="Malgun Gothic" pitchFamily="34" charset="0"/>
+                <a:ea typeface="Malgun Gothic" pitchFamily="34" charset="-122"/>
+                <a:cs typeface="Malgun Gothic" pitchFamily="34" charset="-120"/>
+              </a:rPr>
+              <a:t>표준화</a:t>
+            </a:r>
+            <a:endParaRPr lang="en-US" sz="1150" dirty="0"/>
+          </a:p>
+        </p:txBody>
+      </p:sp>
+      <p:sp>
+        <p:nvSpPr>
+          <p:cNvPr id="69" name="Shape 61"/>
+          <p:cNvSpPr/>
+          <p:nvPr/>
+        </p:nvSpPr>
+        <p:spPr>
+          <a:xfrm>
+            <a:off x="8311896" y="4864608"/>
+            <a:ext cx="3236976" cy="512064"/>
+          </a:xfrm>
+          <a:prstGeom prst="roundRect">
+            <a:avLst>
+              <a:gd name="adj" fmla="val 14286"/>
+            </a:avLst>
+          </a:prstGeom>
+          <a:solidFill>
+            <a:srgbClr val="E8F6F0"/>
+          </a:solidFill>
+          <a:ln w="15875">
             <a:solidFill>
               <a:srgbClr val="02A878"/>
             </a:solidFill>
@@ -3097,55 +3370,59 @@
           </a:ln>
         </p:spPr>
       </p:sp>
-      <p:sp>
-        <p:nvSpPr>
-          <p:cNvPr id="63" name="Shape 55"/>
-          <p:cNvSpPr/>
-          <p:nvPr/>
-        </p:nvSpPr>
-        <p:spPr>
-          <a:xfrm>
-            <a:off x="8631936" y="4764024"/>
-            <a:ext cx="128016" cy="128016"/>
-          </a:xfrm>
-          <a:prstGeom prst="ellipse">
-            <a:avLst/>
-          </a:prstGeom>
-          <a:solidFill>
-            <a:srgbClr val="02A878"/>
-          </a:solidFill>
-          <a:ln/>
-        </p:spPr>
-      </p:sp>
-      <p:sp>
-        <p:nvSpPr>
-          <p:cNvPr id="64" name="Text 56"/>
-          <p:cNvSpPr/>
-          <p:nvPr/>
-        </p:nvSpPr>
-        <p:spPr>
-          <a:xfrm>
-            <a:off x="8147304" y="4956048"/>
-            <a:ext cx="1097280" cy="475488"/>
-          </a:xfrm>
-          <a:prstGeom prst="rect">
-            <a:avLst/>
-          </a:prstGeom>
-          <a:noFill/>
-          <a:ln/>
-        </p:spPr>
-        <p:txBody>
-          <a:bodyPr wrap="square" lIns="0" tIns="0" rIns="0" bIns="0" rtlCol="0" anchor="ctr"/>
-          <a:lstStyle/>
-          <a:p>
-            <a:pPr algn="ctr" indent="0" marL="0">
+      <p:pic>
+        <p:nvPicPr>
+          <p:cNvPr id="70" name="Image 6" descr="preencoded.png">    </p:cNvPr>
+          <p:cNvPicPr>
+            <a:picLocks noChangeAspect="1"/>
+          </p:cNvPicPr>
+          <p:nvPr/>
+        </p:nvPicPr>
+        <p:blipFill>
+          <a:blip r:embed="rId7"/>
+          <a:stretch>
+            <a:fillRect/>
+          </a:stretch>
+        </p:blipFill>
+        <p:spPr>
+          <a:xfrm>
+            <a:off x="8494776" y="4937760"/>
+            <a:ext cx="365760" cy="365760"/>
+          </a:xfrm>
+          <a:prstGeom prst="rect">
+            <a:avLst/>
+          </a:prstGeom>
+        </p:spPr>
+      </p:pic>
+      <p:sp>
+        <p:nvSpPr>
+          <p:cNvPr id="71" name="Text 62"/>
+          <p:cNvSpPr/>
+          <p:nvPr/>
+        </p:nvSpPr>
+        <p:spPr>
+          <a:xfrm>
+            <a:off x="8988552" y="4864608"/>
+            <a:ext cx="2377440" cy="512064"/>
+          </a:xfrm>
+          <a:prstGeom prst="rect">
+            <a:avLst/>
+          </a:prstGeom>
+          <a:noFill/>
+          <a:ln/>
+        </p:spPr>
+        <p:txBody>
+          <a:bodyPr wrap="square" lIns="0" tIns="0" rIns="0" bIns="0" rtlCol="0" anchor="ctr"/>
+          <a:lstStyle/>
+          <a:p>
+            <a:pPr indent="0" marL="0">
               <a:lnSpc>
-                <a:spcPct val="100000"/>
+                <a:spcPct val="112000"/>
               </a:lnSpc>
               <a:buNone/>
             </a:pPr>
             <a:r>
-              <a:rPr lang="en-US" sz="1200" b="1" dirty="0">
+              <a:rPr lang="en-US" sz="1300" b="1" dirty="0">
                 <a:solidFill>
                   <a:srgbClr val="17313B"/>
                 </a:solidFill>
@@ -3153,199 +3430,35 @@
                 <a:ea typeface="Malgun Gothic" pitchFamily="34" charset="-122"/>
                 <a:cs typeface="Malgun Gothic" pitchFamily="34" charset="-120"/>
               </a:rPr>
-              <a:t>90일</a:t>
-            </a:r>
-            <a:endParaRPr lang="en-US" sz="1200" dirty="0"/>
-          </a:p>
-          <a:p>
-            <a:pPr algn="ctr" indent="0" marL="0">
+              <a:t>DE를 스타 플레이어로</a:t>
+            </a:r>
+            <a:endParaRPr lang="en-US" sz="1300" dirty="0"/>
+          </a:p>
+          <a:p>
+            <a:pPr indent="0" marL="0">
               <a:lnSpc>
-                <a:spcPct val="100000"/>
+                <a:spcPct val="112000"/>
               </a:lnSpc>
               <a:buNone/>
             </a:pPr>
             <a:r>
-              <a:rPr lang="en-US" sz="1200" b="1" dirty="0">
-                <a:solidFill>
-                  <a:srgbClr val="17313B"/>
-                </a:solidFill>
-                <a:latin typeface="Malgun Gothic" pitchFamily="34" charset="0"/>
-                <a:ea typeface="Malgun Gothic" pitchFamily="34" charset="-122"/>
-                <a:cs typeface="Malgun Gothic" pitchFamily="34" charset="-120"/>
-              </a:rPr>
-              <a:t>증명</a:t>
-            </a:r>
-            <a:endParaRPr lang="en-US" sz="1200" dirty="0"/>
-          </a:p>
-        </p:txBody>
-      </p:sp>
-      <p:sp>
-        <p:nvSpPr>
-          <p:cNvPr id="65" name="Shape 57"/>
-          <p:cNvSpPr/>
-          <p:nvPr/>
-        </p:nvSpPr>
-        <p:spPr>
-          <a:xfrm>
-            <a:off x="9866376" y="4764024"/>
-            <a:ext cx="128016" cy="128016"/>
-          </a:xfrm>
-          <a:prstGeom prst="ellipse">
-            <a:avLst/>
-          </a:prstGeom>
-          <a:solidFill>
-            <a:srgbClr val="02A878"/>
-          </a:solidFill>
-          <a:ln/>
-        </p:spPr>
-      </p:sp>
-      <p:sp>
-        <p:nvSpPr>
-          <p:cNvPr id="66" name="Text 58"/>
-          <p:cNvSpPr/>
-          <p:nvPr/>
-        </p:nvSpPr>
-        <p:spPr>
-          <a:xfrm>
-            <a:off x="9381744" y="4956048"/>
-            <a:ext cx="1097280" cy="475488"/>
-          </a:xfrm>
-          <a:prstGeom prst="rect">
-            <a:avLst/>
-          </a:prstGeom>
-          <a:noFill/>
-          <a:ln/>
-        </p:spPr>
-        <p:txBody>
-          <a:bodyPr wrap="square" lIns="0" tIns="0" rIns="0" bIns="0" rtlCol="0" anchor="ctr"/>
-          <a:lstStyle/>
-          <a:p>
-            <a:pPr algn="ctr" indent="0" marL="0">
-              <a:lnSpc>
-                <a:spcPct val="100000"/>
-              </a:lnSpc>
-              <a:buNone/>
-            </a:pPr>
-            <a:r>
-              <a:rPr lang="en-US" sz="1200" b="1" dirty="0">
-                <a:solidFill>
-                  <a:srgbClr val="17313B"/>
-                </a:solidFill>
-                <a:latin typeface="Malgun Gothic" pitchFamily="34" charset="0"/>
-                <a:ea typeface="Malgun Gothic" pitchFamily="34" charset="-122"/>
-                <a:cs typeface="Malgun Gothic" pitchFamily="34" charset="-120"/>
-              </a:rPr>
-              <a:t>1년</a:t>
-            </a:r>
-            <a:endParaRPr lang="en-US" sz="1200" dirty="0"/>
-          </a:p>
-          <a:p>
-            <a:pPr algn="ctr" indent="0" marL="0">
-              <a:lnSpc>
-                <a:spcPct val="100000"/>
-              </a:lnSpc>
-              <a:buNone/>
-            </a:pPr>
-            <a:r>
-              <a:rPr lang="en-US" sz="1200" b="1" dirty="0">
-                <a:solidFill>
-                  <a:srgbClr val="17313B"/>
-                </a:solidFill>
-                <a:latin typeface="Malgun Gothic" pitchFamily="34" charset="0"/>
-                <a:ea typeface="Malgun Gothic" pitchFamily="34" charset="-122"/>
-                <a:cs typeface="Malgun Gothic" pitchFamily="34" charset="-120"/>
-              </a:rPr>
-              <a:t>제도화</a:t>
-            </a:r>
-            <a:endParaRPr lang="en-US" sz="1200" dirty="0"/>
-          </a:p>
-        </p:txBody>
-      </p:sp>
-      <p:sp>
-        <p:nvSpPr>
-          <p:cNvPr id="67" name="Shape 59"/>
-          <p:cNvSpPr/>
-          <p:nvPr/>
-        </p:nvSpPr>
-        <p:spPr>
-          <a:xfrm>
-            <a:off x="11100816" y="4764024"/>
-            <a:ext cx="128016" cy="128016"/>
-          </a:xfrm>
-          <a:prstGeom prst="ellipse">
-            <a:avLst/>
-          </a:prstGeom>
-          <a:solidFill>
-            <a:srgbClr val="02A878"/>
-          </a:solidFill>
-          <a:ln/>
-        </p:spPr>
-      </p:sp>
-      <p:sp>
-        <p:nvSpPr>
-          <p:cNvPr id="68" name="Text 60"/>
-          <p:cNvSpPr/>
-          <p:nvPr/>
-        </p:nvSpPr>
-        <p:spPr>
-          <a:xfrm>
-            <a:off x="10616184" y="4956048"/>
-            <a:ext cx="1097280" cy="475488"/>
-          </a:xfrm>
-          <a:prstGeom prst="rect">
-            <a:avLst/>
-          </a:prstGeom>
-          <a:noFill/>
-          <a:ln/>
-        </p:spPr>
-        <p:txBody>
-          <a:bodyPr wrap="square" lIns="0" tIns="0" rIns="0" bIns="0" rtlCol="0" anchor="ctr"/>
-          <a:lstStyle/>
-          <a:p>
-            <a:pPr algn="ctr" indent="0" marL="0">
-              <a:lnSpc>
-                <a:spcPct val="100000"/>
-              </a:lnSpc>
-              <a:buNone/>
-            </a:pPr>
-            <a:r>
-              <a:rPr lang="en-US" sz="1200" b="1" dirty="0">
-                <a:solidFill>
-                  <a:srgbClr val="17313B"/>
-                </a:solidFill>
-                <a:latin typeface="Malgun Gothic" pitchFamily="34" charset="0"/>
-                <a:ea typeface="Malgun Gothic" pitchFamily="34" charset="-122"/>
-                <a:cs typeface="Malgun Gothic" pitchFamily="34" charset="-120"/>
-              </a:rPr>
-              <a:t>3년</a:t>
-            </a:r>
-            <a:endParaRPr lang="en-US" sz="1200" dirty="0"/>
-          </a:p>
-          <a:p>
-            <a:pPr algn="ctr" indent="0" marL="0">
-              <a:lnSpc>
-                <a:spcPct val="100000"/>
-              </a:lnSpc>
-              <a:buNone/>
-            </a:pPr>
-            <a:r>
-              <a:rPr lang="en-US" sz="1200" b="1" dirty="0">
-                <a:solidFill>
-                  <a:srgbClr val="17313B"/>
-                </a:solidFill>
-                <a:latin typeface="Malgun Gothic" pitchFamily="34" charset="0"/>
-                <a:ea typeface="Malgun Gothic" pitchFamily="34" charset="-122"/>
-                <a:cs typeface="Malgun Gothic" pitchFamily="34" charset="-120"/>
-              </a:rPr>
-              <a:t>표준화</a:t>
-            </a:r>
-            <a:endParaRPr lang="en-US" sz="1200" dirty="0"/>
-          </a:p>
-        </p:txBody>
-      </p:sp>
-      <p:sp>
-        <p:nvSpPr>
-          <p:cNvPr id="69" name="Text 61"/>
+              <a:rPr lang="en-US" sz="1050" dirty="0">
+                <a:solidFill>
+                  <a:srgbClr val="5A7184"/>
+                </a:solidFill>
+                <a:latin typeface="Malgun Gothic" pitchFamily="34" charset="0"/>
+                <a:ea typeface="Malgun Gothic" pitchFamily="34" charset="-122"/>
+                <a:cs typeface="Malgun Gothic" pitchFamily="34" charset="-120"/>
+              </a:rPr>
+              <a:t>고객과 기술 생태계 공동 설계</a:t>
+            </a:r>
+            <a:endParaRPr lang="en-US" sz="1300" dirty="0"/>
+          </a:p>
+        </p:txBody>
+      </p:sp>
+      <p:sp>
+        <p:nvSpPr>
+          <p:cNvPr id="72" name="Text 63"/>
           <p:cNvSpPr/>
           <p:nvPr/>
         </p:nvSpPr>
@@ -3370,7 +3483,7 @@
             <a:r>
               <a:rPr lang="en-US" sz="2400" b="1" dirty="0">
                 <a:solidFill>
-                  <a:srgbClr val="028090"/>
+                  <a:srgbClr val="17313B"/>
                 </a:solidFill>
                 <a:latin typeface="Malgun Gothic" pitchFamily="34" charset="0"/>
                 <a:ea typeface="Malgun Gothic" pitchFamily="34" charset="-122"/>
@@ -3384,7 +3497,7 @@
       </p:sp>
       <p:sp>
         <p:nvSpPr>
-          <p:cNvPr id="70" name="Text 62"/>
+          <p:cNvPr id="73" name="Text 64"/>
           <p:cNvSpPr/>
           <p:nvPr/>
         </p:nvSpPr>
@@ -3423,7 +3536,7 @@
       </p:sp>
       <p:sp>
         <p:nvSpPr>
-          <p:cNvPr id="71" name="Text 63"/>
+          <p:cNvPr id="74" name="Text 65"/>
           <p:cNvSpPr/>
           <p:nvPr/>
         </p:nvSpPr>
@@ -3448,7 +3561,7 @@
             <a:r>
               <a:rPr lang="en-US" sz="2400" b="1" dirty="0">
                 <a:solidFill>
-                  <a:srgbClr val="028090"/>
+                  <a:srgbClr val="17313B"/>
                 </a:solidFill>
                 <a:latin typeface="Malgun Gothic" pitchFamily="34" charset="0"/>
                 <a:ea typeface="Malgun Gothic" pitchFamily="34" charset="-122"/>
@@ -3462,7 +3575,7 @@
       </p:sp>
       <p:sp>
         <p:nvSpPr>
-          <p:cNvPr id="72" name="Text 64"/>
+          <p:cNvPr id="75" name="Text 66"/>
           <p:cNvSpPr/>
           <p:nvPr/>
         </p:nvSpPr>
@@ -3501,7 +3614,7 @@
       </p:sp>
       <p:sp>
         <p:nvSpPr>
-          <p:cNvPr id="73" name="Text 65"/>
+          <p:cNvPr id="76" name="Text 67"/>
           <p:cNvSpPr/>
           <p:nvPr/>
         </p:nvSpPr>
@@ -3526,7 +3639,7 @@
             <a:r>
               <a:rPr lang="en-US" sz="2400" b="1" dirty="0">
                 <a:solidFill>
-                  <a:srgbClr val="028090"/>
+                  <a:srgbClr val="17313B"/>
                 </a:solidFill>
                 <a:latin typeface="Malgun Gothic" pitchFamily="34" charset="0"/>
                 <a:ea typeface="Malgun Gothic" pitchFamily="34" charset="-122"/>
@@ -3540,7 +3653,7 @@
       </p:sp>
       <p:sp>
         <p:nvSpPr>
-          <p:cNvPr id="74" name="Text 66"/>
+          <p:cNvPr id="77" name="Text 68"/>
           <p:cNvSpPr/>
           <p:nvPr/>
         </p:nvSpPr>
@@ -3579,7 +3692,7 @@
       </p:sp>
       <p:sp>
         <p:nvSpPr>
-          <p:cNvPr id="75" name="Text 67"/>
+          <p:cNvPr id="78" name="Text 69"/>
           <p:cNvSpPr/>
           <p:nvPr/>
         </p:nvSpPr>
@@ -3604,7 +3717,7 @@
             <a:r>
               <a:rPr lang="en-US" sz="2400" b="1" dirty="0">
                 <a:solidFill>
-                  <a:srgbClr val="028090"/>
+                  <a:srgbClr val="17313B"/>
                 </a:solidFill>
                 <a:latin typeface="Malgun Gothic" pitchFamily="34" charset="0"/>
                 <a:ea typeface="Malgun Gothic" pitchFamily="34" charset="-122"/>
@@ -3618,7 +3731,7 @@
       </p:sp>
       <p:sp>
         <p:nvSpPr>
-          <p:cNvPr id="76" name="Text 68"/>
+          <p:cNvPr id="79" name="Text 70"/>
           <p:cNvSpPr/>
           <p:nvPr/>
         </p:nvSpPr>
@@ -3657,7 +3770,7 @@
       </p:sp>
       <p:sp>
         <p:nvSpPr>
-          <p:cNvPr id="77" name="Text 69"/>
+          <p:cNvPr id="80" name="Text 71"/>
           <p:cNvSpPr/>
           <p:nvPr/>
         </p:nvSpPr>
@@ -3682,7 +3795,7 @@
             <a:r>
               <a:rPr lang="en-US" sz="2400" b="1" dirty="0">
                 <a:solidFill>
-                  <a:srgbClr val="028090"/>
+                  <a:srgbClr val="02A878"/>
                 </a:solidFill>
                 <a:latin typeface="Malgun Gothic" pitchFamily="34" charset="0"/>
                 <a:ea typeface="Malgun Gothic" pitchFamily="34" charset="-122"/>
@@ -3696,7 +3809,7 @@
       </p:sp>
       <p:sp>
         <p:nvSpPr>
-          <p:cNvPr id="78" name="Text 70"/>
+          <p:cNvPr id="81" name="Text 72"/>
           <p:cNvSpPr/>
           <p:nvPr/>
         </p:nvSpPr>

</xml_diff>

<commit_message>
build(pptx): 용어 정비 — DE→FDE(Forward Deployed Engineer)·SCA→전략적 고객 계약 (v2.32.3)
- PPT 3장 전체에서 DE 표기를 FDE로, SCA 약어를 한글 "전략적 고객 계약"으로 교체
- 중 슬라이드 계약 체브런 가변 폭(전략적 고객 계약 박스 확장), 하 슬라이드 화살표 2줄
- DT_DOWNLOADS 설명 갱신, 다운로드 pptx 3종 미러, version v2.32.3 (패치)

Co-Authored-By: Claude Fable 5 <noreply@anthropic.com>
Claude-Session: https://claude.ai/code/session_01P75FajBNDiW5p24ay2HU9V
</commit_message>
<xml_diff>
--- a/dashboard/public/downloads/dev-transformation-summary-high.pptx
+++ b/dashboard/public/downloads/dev-transformation-summary-high.pptx
@@ -1800,7 +1800,27 @@
                 <a:ea typeface="Malgun Gothic" pitchFamily="34" charset="-122"/>
                 <a:cs typeface="Malgun Gothic" pitchFamily="34" charset="-120"/>
               </a:rPr>
-              <a:t>Micron–Anthropic SCA</a:t>
+              <a:t>Micron–Anthropic</a:t>
+            </a:r>
+            <a:endParaRPr lang="en-US" sz="1250" dirty="0"/>
+          </a:p>
+          <a:p>
+            <a:pPr indent="0" marL="0">
+              <a:lnSpc>
+                <a:spcPct val="105000"/>
+              </a:lnSpc>
+              <a:buNone/>
+            </a:pPr>
+            <a:r>
+              <a:rPr lang="en-US" sz="1250" dirty="0">
+                <a:solidFill>
+                  <a:srgbClr val="17313B"/>
+                </a:solidFill>
+                <a:latin typeface="Malgun Gothic" pitchFamily="34" charset="0"/>
+                <a:ea typeface="Malgun Gothic" pitchFamily="34" charset="-122"/>
+                <a:cs typeface="Malgun Gothic" pitchFamily="34" charset="-120"/>
+              </a:rPr>
+              <a:t>전략적 고객 계약</a:t>
             </a:r>
             <a:endParaRPr lang="en-US" sz="1250" dirty="0"/>
           </a:p>
@@ -1913,7 +1933,7 @@
                 <a:ea typeface="Malgun Gothic" pitchFamily="34" charset="-122"/>
                 <a:cs typeface="Malgun Gothic" pitchFamily="34" charset="-120"/>
               </a:rPr>
-              <a:t>납품 정확성만으론</a:t>
+              <a:t>정확한 납품만으로는</a:t>
             </a:r>
             <a:endParaRPr lang="en-US" sz="1400" dirty="0"/>
           </a:p>
@@ -1933,7 +1953,7 @@
                 <a:ea typeface="Malgun Gothic" pitchFamily="34" charset="-122"/>
                 <a:cs typeface="Malgun Gothic" pitchFamily="34" charset="-120"/>
               </a:rPr>
-              <a:t>SCA 테이블에 못 앉는다</a:t>
+              <a:t>전략적 고객 계약 수주 불가</a:t>
             </a:r>
             <a:endParaRPr lang="en-US" sz="1400" dirty="0"/>
           </a:p>
@@ -2999,7 +3019,7 @@
                 <a:ea typeface="Malgun Gothic" pitchFamily="34" charset="-122"/>
                 <a:cs typeface="Malgun Gothic" pitchFamily="34" charset="-120"/>
               </a:rPr>
-              <a:t>DE 스타·Pod 상주</a:t>
+              <a:t>FDE 스타·Pod 상주</a:t>
             </a:r>
             <a:endParaRPr lang="en-US" sz="1050" dirty="0"/>
           </a:p>
@@ -3483,7 +3503,7 @@
                 <a:ea typeface="Malgun Gothic" pitchFamily="34" charset="-122"/>
                 <a:cs typeface="Malgun Gothic" pitchFamily="34" charset="-120"/>
               </a:rPr>
-              <a:t>DE를 스타 플레이어로</a:t>
+              <a:t>FDE를 스타 플레이어로</a:t>
             </a:r>
             <a:endParaRPr lang="en-US" sz="1300" dirty="0"/>
           </a:p>

</xml_diff>